<commit_message>
Rework the closing slides: FAISS and memory trade-offs, and an improvements slide
</commit_message>
<xml_diff>
--- a/Agentic_RAG_Presentation.pptx
+++ b/Agentic_RAG_Presentation.pptx
@@ -5105,8 +5105,8 @@
           <p:nvPr/>
         </p:nvGraphicFramePr>
         <p:xfrm>
-          <a:off x="685800" y="1417320"/>
-          <a:ext cx="10789918" cy="4864608"/>
+          <a:off x="685800" y="1371600"/>
+          <a:ext cx="10789920" cy="4114800"/>
         </p:xfrm>
         <a:graphic>
           <a:graphicData uri="http://schemas.openxmlformats.org/drawingml/2006/table">
@@ -5115,11 +5115,11 @@
                 <a:tableStyleId>{5C22544A-7EE6-4342-B048-85BDC9FD1C3A}</a:tableStyleId>
               </a:tblPr>
               <a:tblGrid>
-                <a:gridCol w="3291840"/>
-                <a:gridCol w="3749039"/>
-                <a:gridCol w="3749039"/>
+                <a:gridCol w="3017520"/>
+                <a:gridCol w="3931920"/>
+                <a:gridCol w="3840480"/>
               </a:tblGrid>
-              <a:tr h="694944">
+              <a:tr h="502920">
                 <a:tc>
                   <a:txBody>
                     <a:bodyPr wrap="square"/>
@@ -5202,14 +5202,14 @@
                   </a:tcPr>
                 </a:tc>
               </a:tr>
-              <a:tr h="694944">
+              <a:tr h="502920">
                 <a:tc>
                   <a:txBody>
                     <a:bodyPr wrap="square"/>
                     <a:lstStyle/>
                     <a:p>
                       <a:r>
-                        <a:rPr sz="1350" b="1">
+                        <a:rPr sz="1200" b="1">
                           <a:solidFill>
                             <a:srgbClr val="121826"/>
                           </a:solidFill>
@@ -5236,7 +5236,7 @@
                     <a:lstStyle/>
                     <a:p>
                       <a:r>
-                        <a:rPr sz="1350" b="0">
+                        <a:rPr sz="1200" b="0">
                           <a:solidFill>
                             <a:srgbClr val="121826"/>
                           </a:solidFill>
@@ -5263,7 +5263,7 @@
                     <a:lstStyle/>
                     <a:p>
                       <a:r>
-                        <a:rPr sz="1350" b="0">
+                        <a:rPr sz="1200" b="0">
                           <a:solidFill>
                             <a:srgbClr val="121826"/>
                           </a:solidFill>
@@ -5285,14 +5285,14 @@
                   </a:tcPr>
                 </a:tc>
               </a:tr>
-              <a:tr h="694944">
+              <a:tr h="502920">
                 <a:tc>
                   <a:txBody>
                     <a:bodyPr wrap="square"/>
                     <a:lstStyle/>
                     <a:p>
                       <a:r>
-                        <a:rPr sz="1350" b="1">
+                        <a:rPr sz="1200" b="1">
                           <a:solidFill>
                             <a:srgbClr val="121826"/>
                           </a:solidFill>
@@ -5319,7 +5319,7 @@
                     <a:lstStyle/>
                     <a:p>
                       <a:r>
-                        <a:rPr sz="1350" b="0">
+                        <a:rPr sz="1200" b="0">
                           <a:solidFill>
                             <a:srgbClr val="121826"/>
                           </a:solidFill>
@@ -5346,7 +5346,7 @@
                     <a:lstStyle/>
                     <a:p>
                       <a:r>
-                        <a:rPr sz="1350" b="0">
+                        <a:rPr sz="1200" b="0">
                           <a:solidFill>
                             <a:srgbClr val="121826"/>
                           </a:solidFill>
@@ -5368,14 +5368,14 @@
                   </a:tcPr>
                 </a:tc>
               </a:tr>
-              <a:tr h="694944">
+              <a:tr h="502920">
                 <a:tc>
                   <a:txBody>
                     <a:bodyPr wrap="square"/>
                     <a:lstStyle/>
                     <a:p>
                       <a:r>
-                        <a:rPr sz="1350" b="1">
+                        <a:rPr sz="1200" b="1">
                           <a:solidFill>
                             <a:srgbClr val="121826"/>
                           </a:solidFill>
@@ -5402,7 +5402,7 @@
                     <a:lstStyle/>
                     <a:p>
                       <a:r>
-                        <a:rPr sz="1350" b="0">
+                        <a:rPr sz="1200" b="0">
                           <a:solidFill>
                             <a:srgbClr val="121826"/>
                           </a:solidFill>
@@ -5429,7 +5429,7 @@
                     <a:lstStyle/>
                     <a:p>
                       <a:r>
-                        <a:rPr sz="1350" b="0">
+                        <a:rPr sz="1200" b="0">
                           <a:solidFill>
                             <a:srgbClr val="121826"/>
                           </a:solidFill>
@@ -5451,14 +5451,97 @@
                   </a:tcPr>
                 </a:tc>
               </a:tr>
-              <a:tr h="694944">
+              <a:tr h="502920">
                 <a:tc>
                   <a:txBody>
                     <a:bodyPr wrap="square"/>
                     <a:lstStyle/>
                     <a:p>
                       <a:r>
-                        <a:rPr sz="1350" b="1">
+                        <a:rPr sz="1200" b="1">
+                          <a:solidFill>
+                            <a:srgbClr val="121826"/>
+                          </a:solidFill>
+                          <a:latin typeface="Calibri"/>
+                        </a:rPr>
+                        <a:t>FAISS flat index</a:t>
+                      </a:r>
+                    </a:p>
+                  </a:txBody>
+                  <a:tcPr marL="18288" marR="109728" marT="64008" marB="64008" anchor="t">
+                    <a:solidFill>
+                      <a:srgbClr val="FFFFFF"/>
+                    </a:solidFill>
+                    <a:lnB w="9525" cap="flat">
+                      <a:solidFill>
+                        <a:srgbClr val="E4EAF2"/>
+                      </a:solidFill>
+                    </a:lnB>
+                  </a:tcPr>
+                </a:tc>
+                <a:tc>
+                  <a:txBody>
+                    <a:bodyPr wrap="square"/>
+                    <a:lstStyle/>
+                    <a:p>
+                      <a:r>
+                        <a:rPr sz="1200" b="0">
+                          <a:solidFill>
+                            <a:srgbClr val="121826"/>
+                          </a:solidFill>
+                          <a:latin typeface="Calibri"/>
+                        </a:rPr>
+                        <a:t>1,292 chunks — exact search, 1.9 MB, nothing to tune</a:t>
+                      </a:r>
+                    </a:p>
+                  </a:txBody>
+                  <a:tcPr marL="18288" marR="109728" marT="64008" marB="64008" anchor="t">
+                    <a:solidFill>
+                      <a:srgbClr val="FFFFFF"/>
+                    </a:solidFill>
+                    <a:lnB w="9525" cap="flat">
+                      <a:solidFill>
+                        <a:srgbClr val="E4EAF2"/>
+                      </a:solidFill>
+                    </a:lnB>
+                  </a:tcPr>
+                </a:tc>
+                <a:tc>
+                  <a:txBody>
+                    <a:bodyPr wrap="square"/>
+                    <a:lstStyle/>
+                    <a:p>
+                      <a:r>
+                        <a:rPr sz="1200" b="0">
+                          <a:solidFill>
+                            <a:srgbClr val="121826"/>
+                          </a:solidFill>
+                          <a:latin typeface="Calibri"/>
+                        </a:rPr>
+                        <a:t>Brute force, and held in memory; needs HNSW at scale</a:t>
+                      </a:r>
+                    </a:p>
+                  </a:txBody>
+                  <a:tcPr marL="18288" marR="109728" marT="64008" marB="64008" anchor="t">
+                    <a:solidFill>
+                      <a:srgbClr val="FFFFFF"/>
+                    </a:solidFill>
+                    <a:lnB w="9525" cap="flat">
+                      <a:solidFill>
+                        <a:srgbClr val="E4EAF2"/>
+                      </a:solidFill>
+                    </a:lnB>
+                  </a:tcPr>
+                </a:tc>
+              </a:tr>
+              <a:tr h="502920">
+                <a:tc>
+                  <a:txBody>
+                    <a:bodyPr wrap="square"/>
+                    <a:lstStyle/>
+                    <a:p>
+                      <a:r>
+                        <a:rPr sz="1200" b="1">
                           <a:solidFill>
                             <a:srgbClr val="121826"/>
                           </a:solidFill>
@@ -5485,7 +5568,7 @@
                     <a:lstStyle/>
                     <a:p>
                       <a:r>
-                        <a:rPr sz="1350" b="0">
+                        <a:rPr sz="1200" b="0">
                           <a:solidFill>
                             <a:srgbClr val="121826"/>
                           </a:solidFill>
@@ -5512,7 +5595,7 @@
                     <a:lstStyle/>
                     <a:p>
                       <a:r>
-                        <a:rPr sz="1350" b="0">
+                        <a:rPr sz="1200" b="0">
                           <a:solidFill>
                             <a:srgbClr val="121826"/>
                           </a:solidFill>
@@ -5534,14 +5617,14 @@
                   </a:tcPr>
                 </a:tc>
               </a:tr>
-              <a:tr h="694944">
+              <a:tr h="548640">
                 <a:tc>
                   <a:txBody>
                     <a:bodyPr wrap="square"/>
                     <a:lstStyle/>
                     <a:p>
                       <a:r>
-                        <a:rPr sz="1350" b="1">
+                        <a:rPr sz="1200" b="1">
                           <a:solidFill>
                             <a:srgbClr val="121826"/>
                           </a:solidFill>
@@ -5568,13 +5651,13 @@
                     <a:lstStyle/>
                     <a:p>
                       <a:r>
-                        <a:rPr sz="1350" b="0">
+                        <a:rPr sz="1200" b="0">
                           <a:solidFill>
                             <a:srgbClr val="121826"/>
                           </a:solidFill>
                           <a:latin typeface="Calibri"/>
                         </a:rPr>
-                        <a:t>Follow-ups work without context creeping</a:t>
+                        <a:t>Enough for a chain of follow-ups; longer and old turns pull the planner off topic</a:t>
                       </a:r>
                     </a:p>
                   </a:txBody>
@@ -5595,7 +5678,7 @@
                     <a:lstStyle/>
                     <a:p>
                       <a:r>
-                        <a:rPr sz="1350" b="0">
+                        <a:rPr sz="1200" b="0">
                           <a:solidFill>
                             <a:srgbClr val="121826"/>
                           </a:solidFill>
@@ -5617,20 +5700,20 @@
                   </a:tcPr>
                 </a:tc>
               </a:tr>
-              <a:tr h="694944">
+              <a:tr h="548640">
                 <a:tc>
                   <a:txBody>
                     <a:bodyPr wrap="square"/>
                     <a:lstStyle/>
                     <a:p>
                       <a:r>
-                        <a:rPr sz="1350" b="1">
+                        <a:rPr sz="1200" b="1">
                           <a:solidFill>
                             <a:srgbClr val="121826"/>
                           </a:solidFill>
                           <a:latin typeface="Calibri"/>
                         </a:rPr>
-                        <a:t>Four passages per sub-question</a:t>
+                        <a:t>No internet lookup</a:t>
                       </a:r>
                     </a:p>
                   </a:txBody>
@@ -5646,13 +5729,13 @@
                     <a:lstStyle/>
                     <a:p>
                       <a:r>
-                        <a:rPr sz="1350" b="0">
+                        <a:rPr sz="1200" b="0">
                           <a:solidFill>
                             <a:srgbClr val="121826"/>
                           </a:solidFill>
                           <a:latin typeface="Calibri"/>
                         </a:rPr>
-                        <a:t>Keeps citations checkable</a:t>
+                        <a:t>Every answer traces to a filing I control</a:t>
                       </a:r>
                     </a:p>
                   </a:txBody>
@@ -5668,13 +5751,13 @@
                     <a:lstStyle/>
                     <a:p>
                       <a:r>
-                        <a:rPr sz="1350" b="0">
+                        <a:rPr sz="1200" b="0">
                           <a:solidFill>
                             <a:srgbClr val="121826"/>
                           </a:solidFill>
                           <a:latin typeface="Calibri"/>
                         </a:rPr>
-                        <a:t>A broad question may want more context</a:t>
+                        <a:t>Nothing after the filing date; no defined way to fetch or trust a live source</a:t>
                       </a:r>
                     </a:p>
                   </a:txBody>
@@ -5689,6 +5772,116 @@
           </a:graphicData>
         </a:graphic>
       </p:graphicFrame>
+      <p:sp>
+        <p:nvSpPr>
+          <p:cNvPr id="4" name="Rectangle 3"/>
+          <p:cNvSpPr/>
+          <p:nvPr/>
+        </p:nvSpPr>
+        <p:spPr>
+          <a:xfrm>
+            <a:off x="685800" y="5687568"/>
+            <a:ext cx="10820095" cy="10972"/>
+          </a:xfrm>
+          <a:prstGeom prst="rect">
+            <a:avLst/>
+          </a:prstGeom>
+          <a:solidFill>
+            <a:srgbClr val="DBE2ED"/>
+          </a:solidFill>
+          <a:ln>
+            <a:noFill/>
+          </a:ln>
+          <a:effectLst/>
+        </p:spPr>
+        <p:style>
+          <a:lnRef idx="1">
+            <a:schemeClr val="accent1"/>
+          </a:lnRef>
+          <a:fillRef idx="3">
+            <a:schemeClr val="accent1"/>
+          </a:fillRef>
+          <a:effectRef idx="2">
+            <a:schemeClr val="accent1"/>
+          </a:effectRef>
+          <a:fontRef idx="minor">
+            <a:schemeClr val="lt1"/>
+          </a:fontRef>
+        </p:style>
+        <p:txBody>
+          <a:bodyPr rtlCol="0" anchor="ctr"/>
+          <a:lstStyle/>
+          <a:p>
+            <a:pPr algn="ctr"/>
+          </a:p>
+        </p:txBody>
+      </p:sp>
+      <p:sp>
+        <p:nvSpPr>
+          <p:cNvPr id="5" name="TextBox 4"/>
+          <p:cNvSpPr txBox="1"/>
+          <p:nvPr/>
+        </p:nvSpPr>
+        <p:spPr>
+          <a:xfrm>
+            <a:off x="685800" y="5815583"/>
+            <a:ext cx="10820095" cy="822960"/>
+          </a:xfrm>
+          <a:prstGeom prst="rect">
+            <a:avLst/>
+          </a:prstGeom>
+          <a:noFill/>
+        </p:spPr>
+        <p:txBody>
+          <a:bodyPr wrap="square" lIns="0" rIns="0" tIns="0" bIns="0">
+            <a:spAutoFit/>
+          </a:bodyPr>
+          <a:lstStyle/>
+          <a:p>
+            <a:pPr>
+              <a:lnSpc>
+                <a:spcPct val="125000"/>
+              </a:lnSpc>
+            </a:pPr>
+            <a:r>
+              <a:rPr sz="1150" b="1">
+                <a:solidFill>
+                  <a:srgbClr val="B06A00"/>
+                </a:solidFill>
+                <a:latin typeface="Calibri"/>
+              </a:rPr>
+              <a:t>Assumes</a:t>
+            </a:r>
+            <a:r>
+              <a:rPr sz="1150" b="0">
+                <a:solidFill>
+                  <a:srgbClr val="5B6678"/>
+                </a:solidFill>
+                <a:latin typeface="Calibri"/>
+              </a:rPr>
+              <a:t> one 10-K per company per year, and that the Item split from </a:t>
+            </a:r>
+            <a:r>
+              <a:rPr sz="1150" b="0">
+                <a:solidFill>
+                  <a:srgbClr val="5B6678"/>
+                </a:solidFill>
+                <a:latin typeface="Consolas"/>
+              </a:rPr>
+              <a:t>edgartools</a:t>
+            </a:r>
+            <a:r>
+              <a:rPr sz="1150" b="0">
+                <a:solidFill>
+                  <a:srgbClr val="5B6678"/>
+                </a:solidFill>
+                <a:latin typeface="Calibri"/>
+              </a:rPr>
+              <a:t> is correct.</a:t>
+            </a:r>
+          </a:p>
+        </p:txBody>
+      </p:sp>
     </p:spTree>
   </p:cSld>
   <p:clrMapOvr>
@@ -5744,7 +5937,7 @@
                 </a:solidFill>
                 <a:latin typeface="Calibri"/>
               </a:rPr>
-              <a:t>Limits, assumptions, next</a:t>
+              <a:t>What I would build next</a:t>
             </a:r>
           </a:p>
         </p:txBody>
@@ -5757,7 +5950,7 @@
         </p:nvSpPr>
         <p:spPr>
           <a:xfrm>
-            <a:off x="685800" y="1417320"/>
+            <a:off x="685800" y="2102675"/>
             <a:ext cx="5394960" cy="237744"/>
           </a:xfrm>
           <a:prstGeom prst="rect">
@@ -5778,7 +5971,7 @@
                 </a:solidFill>
                 <a:latin typeface="Consolas"/>
               </a:rPr>
-              <a:t>KNOWN LIMITS</a:t>
+              <a:t>MAKE IT HOLD AT SCALE</a:t>
             </a:r>
           </a:p>
         </p:txBody>
@@ -5791,7 +5984,7 @@
         </p:nvSpPr>
         <p:spPr>
           <a:xfrm>
-            <a:off x="685800" y="1655064"/>
+            <a:off x="685800" y="2340419"/>
             <a:ext cx="5394960" cy="10972"/>
           </a:xfrm>
           <a:prstGeom prst="rect">
@@ -5835,8 +6028,8 @@
         </p:nvSpPr>
         <p:spPr>
           <a:xfrm>
-            <a:off x="685800" y="1801368"/>
-            <a:ext cx="5394960" cy="4507992"/>
+            <a:off x="685800" y="2486723"/>
+            <a:ext cx="5394960" cy="4553712"/>
           </a:xfrm>
           <a:prstGeom prst="rect">
             <a:avLst/>
@@ -5860,37 +6053,28 @@
             <a:r>
               <a:rPr sz="775">
                 <a:solidFill>
-                  <a:srgbClr val="C3CCDA"/>
+                  <a:srgbClr val="0C7A6D"/>
                 </a:solidFill>
               </a:rPr>
               <a:t>■  </a:t>
             </a:r>
             <a:r>
+              <a:rPr sz="1250" b="1">
+                <a:solidFill>
+                  <a:srgbClr val="0C7A6D"/>
+                </a:solidFill>
+                <a:latin typeface="Calibri"/>
+              </a:rPr>
+              <a:t>Swap the index.</a:t>
+            </a:r>
+            <a:r>
               <a:rPr sz="1250" b="0">
                 <a:solidFill>
                   <a:srgbClr val="121826"/>
                 </a:solidFill>
                 <a:latin typeface="Calibri"/>
               </a:rPr>
-              <a:t>Passages are </a:t>
-            </a:r>
-            <a:r>
-              <a:rPr sz="1250" b="1">
-                <a:solidFill>
-                  <a:srgbClr val="B06A00"/>
-                </a:solidFill>
-                <a:latin typeface="Calibri"/>
-              </a:rPr>
-              <a:t>replaced</a:t>
-            </a:r>
-            <a:r>
-              <a:rPr sz="1250" b="0">
-                <a:solidFill>
-                  <a:srgbClr val="121826"/>
-                </a:solidFill>
-                <a:latin typeface="Calibri"/>
-              </a:rPr>
-              <a:t> on a retry, not added up — a chunk found early can be lost later.</a:t>
+              <a:t> FAISS flat scans everything and lives in RAM. HNSW or IVF for the vectors, and a real inverted index for the keyword arm — BM25 currently scores all 1,292 chunks on every query.</a:t>
             </a:r>
           </a:p>
           <a:p>
@@ -5905,19 +6089,64 @@
             <a:r>
               <a:rPr sz="775">
                 <a:solidFill>
-                  <a:srgbClr val="C3CCDA"/>
+                  <a:srgbClr val="0C7A6D"/>
                 </a:solidFill>
               </a:rPr>
               <a:t>■  </a:t>
             </a:r>
             <a:r>
+              <a:rPr sz="1250" b="1">
+                <a:solidFill>
+                  <a:srgbClr val="0C7A6D"/>
+                </a:solidFill>
+                <a:latin typeface="Calibri"/>
+              </a:rPr>
+              <a:t>Move the state out of process.</a:t>
+            </a:r>
+            <a:r>
               <a:rPr sz="1250" b="0">
                 <a:solidFill>
                   <a:srgbClr val="121826"/>
                 </a:solidFill>
                 <a:latin typeface="Calibri"/>
               </a:rPr>
-              <a:t>Narrative text only; figures inside financial tables are the weakest case.</a:t>
+              <a:t> </a:t>
+            </a:r>
+            <a:r>
+              <a:rPr sz="1250" b="0">
+                <a:solidFill>
+                  <a:srgbClr val="121826"/>
+                </a:solidFill>
+                <a:latin typeface="Consolas"/>
+              </a:rPr>
+              <a:t>PostgresSaver</a:t>
+            </a:r>
+            <a:r>
+              <a:rPr sz="1250" b="0">
+                <a:solidFill>
+                  <a:srgbClr val="121826"/>
+                </a:solidFill>
+                <a:latin typeface="Calibri"/>
+              </a:rPr>
+              <a:t> instead of </a:t>
+            </a:r>
+            <a:r>
+              <a:rPr sz="1250" b="0">
+                <a:solidFill>
+                  <a:srgbClr val="121826"/>
+                </a:solidFill>
+                <a:latin typeface="Consolas"/>
+              </a:rPr>
+              <a:t>MemorySaver</a:t>
+            </a:r>
+            <a:r>
+              <a:rPr sz="1250" b="0">
+                <a:solidFill>
+                  <a:srgbClr val="121826"/>
+                </a:solidFill>
+                <a:latin typeface="Calibri"/>
+              </a:rPr>
+              <a:t>, so a paused question survives a restart and works across replicas.</a:t>
             </a:r>
           </a:p>
           <a:p>
@@ -5932,7 +6161,7 @@
             <a:r>
               <a:rPr sz="775">
                 <a:solidFill>
-                  <a:srgbClr val="C3CCDA"/>
+                  <a:srgbClr val="0C7A6D"/>
                 </a:solidFill>
               </a:rPr>
               <a:t>■  </a:t>
@@ -5940,11 +6169,11 @@
             <a:r>
               <a:rPr sz="1250" b="1">
                 <a:solidFill>
-                  <a:srgbClr val="B06A00"/>
-                </a:solidFill>
-                <a:latin typeface="Calibri"/>
-              </a:rPr>
-              <a:t>Recall is not measured.</a:t>
+                  <a:srgbClr val="0C7A6D"/>
+                </a:solidFill>
+                <a:latin typeface="Calibri"/>
+              </a:rPr>
+              <a:t>Cache.</a:t>
             </a:r>
             <a:r>
               <a:rPr sz="1250" b="0">
@@ -5953,9 +6182,110 @@
                 </a:solidFill>
                 <a:latin typeface="Calibri"/>
               </a:rPr>
-              <a:t> I can show answers are grounded in what was retrieved, not that retrieval found everything it should have.</a:t>
-            </a:r>
-          </a:p>
+              <a:t> Plans and answers for repeated questions, and the embedding of a query I have already seen. Most of the cost is the model, not the search.</a:t>
+            </a:r>
+          </a:p>
+        </p:txBody>
+      </p:sp>
+      <p:sp>
+        <p:nvSpPr>
+          <p:cNvPr id="6" name="TextBox 5"/>
+          <p:cNvSpPr txBox="1"/>
+          <p:nvPr/>
+        </p:nvSpPr>
+        <p:spPr>
+          <a:xfrm>
+            <a:off x="6446520" y="2102675"/>
+            <a:ext cx="5029200" cy="237744"/>
+          </a:xfrm>
+          <a:prstGeom prst="rect">
+            <a:avLst/>
+          </a:prstGeom>
+          <a:noFill/>
+        </p:spPr>
+        <p:txBody>
+          <a:bodyPr wrap="square" lIns="0" rIns="0" tIns="0" bIns="0">
+            <a:spAutoFit/>
+          </a:bodyPr>
+          <a:lstStyle/>
+          <a:p>
+            <a:r>
+              <a:rPr sz="950">
+                <a:solidFill>
+                  <a:srgbClr val="5B6678"/>
+                </a:solidFill>
+                <a:latin typeface="Consolas"/>
+              </a:rPr>
+              <a:t>MAKE IT KNOW MORE, AND KNOW IT BETTER</a:t>
+            </a:r>
+          </a:p>
+        </p:txBody>
+      </p:sp>
+      <p:sp>
+        <p:nvSpPr>
+          <p:cNvPr id="7" name="Rectangle 6"/>
+          <p:cNvSpPr/>
+          <p:nvPr/>
+        </p:nvSpPr>
+        <p:spPr>
+          <a:xfrm>
+            <a:off x="6446520" y="2340419"/>
+            <a:ext cx="5029200" cy="10972"/>
+          </a:xfrm>
+          <a:prstGeom prst="rect">
+            <a:avLst/>
+          </a:prstGeom>
+          <a:solidFill>
+            <a:srgbClr val="DBE2ED"/>
+          </a:solidFill>
+          <a:ln>
+            <a:noFill/>
+          </a:ln>
+          <a:effectLst/>
+        </p:spPr>
+        <p:style>
+          <a:lnRef idx="1">
+            <a:schemeClr val="accent1"/>
+          </a:lnRef>
+          <a:fillRef idx="3">
+            <a:schemeClr val="accent1"/>
+          </a:fillRef>
+          <a:effectRef idx="2">
+            <a:schemeClr val="accent1"/>
+          </a:effectRef>
+          <a:fontRef idx="minor">
+            <a:schemeClr val="lt1"/>
+          </a:fontRef>
+        </p:style>
+        <p:txBody>
+          <a:bodyPr rtlCol="0" anchor="ctr"/>
+          <a:lstStyle/>
+          <a:p>
+            <a:pPr algn="ctr"/>
+          </a:p>
+        </p:txBody>
+      </p:sp>
+      <p:sp>
+        <p:nvSpPr>
+          <p:cNvPr id="8" name="TextBox 7"/>
+          <p:cNvSpPr txBox="1"/>
+          <p:nvPr/>
+        </p:nvSpPr>
+        <p:spPr>
+          <a:xfrm>
+            <a:off x="6446520" y="2486723"/>
+            <a:ext cx="5029200" cy="4553712"/>
+          </a:xfrm>
+          <a:prstGeom prst="rect">
+            <a:avLst/>
+          </a:prstGeom>
+          <a:noFill/>
+        </p:spPr>
+        <p:txBody>
+          <a:bodyPr wrap="square" lIns="0" rIns="0" tIns="0" bIns="0">
+            <a:spAutoFit/>
+          </a:bodyPr>
+          <a:lstStyle/>
           <a:p>
             <a:pPr>
               <a:lnSpc>
@@ -5968,19 +6298,28 @@
             <a:r>
               <a:rPr sz="775">
                 <a:solidFill>
-                  <a:srgbClr val="C3CCDA"/>
+                  <a:srgbClr val="B06A00"/>
                 </a:solidFill>
               </a:rPr>
               <a:t>■  </a:t>
             </a:r>
             <a:r>
+              <a:rPr sz="1250" b="1">
+                <a:solidFill>
+                  <a:srgbClr val="B06A00"/>
+                </a:solidFill>
+                <a:latin typeface="Calibri"/>
+              </a:rPr>
+              <a:t>Reach outside the corpus.</a:t>
+            </a:r>
+            <a:r>
               <a:rPr sz="1250" b="0">
                 <a:solidFill>
                   <a:srgbClr val="121826"/>
                 </a:solidFill>
                 <a:latin typeface="Calibri"/>
               </a:rPr>
-              <a:t>One clarification per question, then it proceeds on a best guess.</a:t>
+              <a:t> Fetch newer filings on demand, and let the agent search the web when the filings genuinely cannot answer — with the same rule as now: cite the source or say you could not find it.</a:t>
             </a:r>
           </a:p>
           <a:p>
@@ -5995,122 +6334,30 @@
             <a:r>
               <a:rPr sz="775">
                 <a:solidFill>
-                  <a:srgbClr val="C3CCDA"/>
+                  <a:srgbClr val="B06A00"/>
                 </a:solidFill>
               </a:rPr>
               <a:t>■  </a:t>
             </a:r>
             <a:r>
+              <a:rPr sz="1250" b="1">
+                <a:solidFill>
+                  <a:srgbClr val="B06A00"/>
+                </a:solidFill>
+                <a:latin typeface="Calibri"/>
+              </a:rPr>
+              <a:t>Widen the eval.</a:t>
+            </a:r>
+            <a:r>
               <a:rPr sz="1250" b="0">
                 <a:solidFill>
                   <a:srgbClr val="121826"/>
                 </a:solidFill>
                 <a:latin typeface="Calibri"/>
               </a:rPr>
-              <a:t>Ten filings, so most of EDGAR is out of scope — refusing is often the correct answer.</a:t>
-            </a:r>
-          </a:p>
-        </p:txBody>
-      </p:sp>
-      <p:sp>
-        <p:nvSpPr>
-          <p:cNvPr id="6" name="TextBox 5"/>
-          <p:cNvSpPr txBox="1"/>
-          <p:nvPr/>
-        </p:nvSpPr>
-        <p:spPr>
-          <a:xfrm>
-            <a:off x="6446520" y="1417320"/>
-            <a:ext cx="5029200" cy="237744"/>
-          </a:xfrm>
-          <a:prstGeom prst="rect">
-            <a:avLst/>
-          </a:prstGeom>
-          <a:noFill/>
-        </p:spPr>
-        <p:txBody>
-          <a:bodyPr wrap="square" lIns="0" rIns="0" tIns="0" bIns="0">
-            <a:spAutoFit/>
-          </a:bodyPr>
-          <a:lstStyle/>
-          <a:p>
-            <a:r>
-              <a:rPr sz="950">
-                <a:solidFill>
-                  <a:srgbClr val="5B6678"/>
-                </a:solidFill>
-                <a:latin typeface="Consolas"/>
-              </a:rPr>
-              <a:t>ASSUMPTIONS I MADE</a:t>
-            </a:r>
-          </a:p>
-        </p:txBody>
-      </p:sp>
-      <p:sp>
-        <p:nvSpPr>
-          <p:cNvPr id="7" name="Rectangle 6"/>
-          <p:cNvSpPr/>
-          <p:nvPr/>
-        </p:nvSpPr>
-        <p:spPr>
-          <a:xfrm>
-            <a:off x="6446520" y="1655064"/>
-            <a:ext cx="5029200" cy="10972"/>
-          </a:xfrm>
-          <a:prstGeom prst="rect">
-            <a:avLst/>
-          </a:prstGeom>
-          <a:solidFill>
-            <a:srgbClr val="DBE2ED"/>
-          </a:solidFill>
-          <a:ln>
-            <a:noFill/>
-          </a:ln>
-          <a:effectLst/>
-        </p:spPr>
-        <p:style>
-          <a:lnRef idx="1">
-            <a:schemeClr val="accent1"/>
-          </a:lnRef>
-          <a:fillRef idx="3">
-            <a:schemeClr val="accent1"/>
-          </a:fillRef>
-          <a:effectRef idx="2">
-            <a:schemeClr val="accent1"/>
-          </a:effectRef>
-          <a:fontRef idx="minor">
-            <a:schemeClr val="lt1"/>
-          </a:fontRef>
-        </p:style>
-        <p:txBody>
-          <a:bodyPr rtlCol="0" anchor="ctr"/>
-          <a:lstStyle/>
-          <a:p>
-            <a:pPr algn="ctr"/>
-          </a:p>
-        </p:txBody>
-      </p:sp>
-      <p:sp>
-        <p:nvSpPr>
-          <p:cNvPr id="8" name="TextBox 7"/>
-          <p:cNvSpPr txBox="1"/>
-          <p:nvPr/>
-        </p:nvSpPr>
-        <p:spPr>
-          <a:xfrm>
-            <a:off x="6446520" y="1801368"/>
-            <a:ext cx="5029200" cy="4507992"/>
-          </a:xfrm>
-          <a:prstGeom prst="rect">
-            <a:avLst/>
-          </a:prstGeom>
-          <a:noFill/>
-        </p:spPr>
-        <p:txBody>
-          <a:bodyPr wrap="square" lIns="0" rIns="0" tIns="0" bIns="0">
-            <a:spAutoFit/>
-          </a:bodyPr>
-          <a:lstStyle/>
+              <a:t> Recall against labelled chunks, and many more routing cases so the 20/20 is a trend rather than a single run.</a:t>
+            </a:r>
+          </a:p>
           <a:p>
             <a:pPr>
               <a:lnSpc>
@@ -6121,21 +6368,30 @@
               </a:spcAft>
             </a:pPr>
             <a:r>
-              <a:rPr sz="744">
-                <a:solidFill>
-                  <a:srgbClr val="0C7A6D"/>
+              <a:rPr sz="775">
+                <a:solidFill>
+                  <a:srgbClr val="B06A00"/>
                 </a:solidFill>
               </a:rPr>
               <a:t>■  </a:t>
             </a:r>
             <a:r>
-              <a:rPr sz="1200" b="0">
+              <a:rPr sz="1250" b="1">
+                <a:solidFill>
+                  <a:srgbClr val="B06A00"/>
+                </a:solidFill>
+                <a:latin typeface="Calibri"/>
+              </a:rPr>
+              <a:t>A model per job.</a:t>
+            </a:r>
+            <a:r>
+              <a:rPr sz="1250" b="0">
                 <a:solidFill>
                   <a:srgbClr val="121826"/>
                 </a:solidFill>
                 <a:latin typeface="Calibri"/>
               </a:rPr>
-              <a:t>One 10-K per company per year, and the fiscal year comes from the filing's own metadata.</a:t>
+              <a:t> A small fast model for pulling out the ticker and year, the large one only where the decision is expensive.</a:t>
             </a:r>
           </a:p>
           <a:p>
@@ -6148,114 +6404,44 @@
               </a:spcAft>
             </a:pPr>
             <a:r>
-              <a:rPr sz="744">
-                <a:solidFill>
-                  <a:srgbClr val="0C7A6D"/>
+              <a:rPr sz="775">
+                <a:solidFill>
+                  <a:srgbClr val="B06A00"/>
                 </a:solidFill>
               </a:rPr>
               <a:t>■  </a:t>
             </a:r>
             <a:r>
-              <a:rPr sz="1200" b="0">
+              <a:rPr sz="1250" b="1">
+                <a:solidFill>
+                  <a:srgbClr val="B06A00"/>
+                </a:solidFill>
+                <a:latin typeface="Calibri"/>
+              </a:rPr>
+              <a:t>Accumulate passages across retries</a:t>
+            </a:r>
+            <a:r>
+              <a:rPr sz="1250" b="0">
                 <a:solidFill>
                   <a:srgbClr val="121826"/>
                 </a:solidFill>
                 <a:latin typeface="Calibri"/>
               </a:rPr>
-              <a:t>The Item split from </a:t>
-            </a:r>
-            <a:r>
-              <a:rPr sz="1200" b="0">
-                <a:solidFill>
-                  <a:srgbClr val="121826"/>
-                </a:solidFill>
-                <a:latin typeface="Consolas"/>
-              </a:rPr>
-              <a:t>edgartools</a:t>
-            </a:r>
-            <a:r>
-              <a:rPr sz="1200" b="0">
-                <a:solidFill>
-                  <a:srgbClr val="121826"/>
-                </a:solidFill>
-                <a:latin typeface="Calibri"/>
-              </a:rPr>
-              <a:t> is correct — I did not verify it against the raw HTML.</a:t>
-            </a:r>
-          </a:p>
-          <a:p>
-            <a:pPr>
-              <a:lnSpc>
-                <a:spcPct val="115000"/>
-              </a:lnSpc>
-              <a:spcAft>
-                <a:spcPts val="792"/>
-              </a:spcAft>
-            </a:pPr>
-            <a:r>
-              <a:rPr sz="744">
-                <a:solidFill>
-                  <a:srgbClr val="0C7A6D"/>
-                </a:solidFill>
-              </a:rPr>
-              <a:t>■  </a:t>
-            </a:r>
-            <a:r>
-              <a:rPr sz="1200" b="0">
-                <a:solidFill>
-                  <a:srgbClr val="121826"/>
-                </a:solidFill>
-                <a:latin typeface="Calibri"/>
-              </a:rPr>
-              <a:t>The three indices agree because one pass writes them; nothing enforces it afterwards.</a:t>
-            </a:r>
-          </a:p>
-        </p:txBody>
-      </p:sp>
-      <p:sp>
-        <p:nvSpPr>
-          <p:cNvPr id="9" name="TextBox 8"/>
-          <p:cNvSpPr txBox="1"/>
-          <p:nvPr/>
-        </p:nvSpPr>
-        <p:spPr>
-          <a:xfrm>
-            <a:off x="6446520" y="3794760"/>
-            <a:ext cx="5029200" cy="237744"/>
-          </a:xfrm>
-          <a:prstGeom prst="rect">
-            <a:avLst/>
-          </a:prstGeom>
-          <a:noFill/>
-        </p:spPr>
-        <p:txBody>
-          <a:bodyPr wrap="square" lIns="0" rIns="0" tIns="0" bIns="0">
-            <a:spAutoFit/>
-          </a:bodyPr>
-          <a:lstStyle/>
-          <a:p>
-            <a:r>
-              <a:rPr sz="950">
-                <a:solidFill>
-                  <a:srgbClr val="5B6678"/>
-                </a:solidFill>
-                <a:latin typeface="Consolas"/>
-              </a:rPr>
-              <a:t>IF I KEPT GOING</a:t>
-            </a:r>
-          </a:p>
-        </p:txBody>
-      </p:sp>
-      <p:sp>
-        <p:nvSpPr>
-          <p:cNvPr id="10" name="Rectangle 9"/>
+              <a:t> — one field, and the single change most likely to improve answers today.</a:t>
+            </a:r>
+          </a:p>
+        </p:txBody>
+      </p:sp>
+      <p:sp>
+        <p:nvSpPr>
+          <p:cNvPr id="9" name="Rectangle 8"/>
           <p:cNvSpPr/>
           <p:nvPr/>
         </p:nvSpPr>
         <p:spPr>
           <a:xfrm>
-            <a:off x="6446520" y="4032504"/>
-            <a:ext cx="5029200" cy="10972"/>
+            <a:off x="685800" y="5205539"/>
+            <a:ext cx="10820095" cy="10972"/>
           </a:xfrm>
           <a:prstGeom prst="rect">
             <a:avLst/>
@@ -6292,161 +6478,13 @@
       </p:sp>
       <p:sp>
         <p:nvSpPr>
-          <p:cNvPr id="11" name="TextBox 10"/>
+          <p:cNvPr id="10" name="TextBox 9"/>
           <p:cNvSpPr txBox="1"/>
           <p:nvPr/>
         </p:nvSpPr>
         <p:spPr>
           <a:xfrm>
-            <a:off x="6446520" y="4178808"/>
-            <a:ext cx="5029200" cy="2130551"/>
-          </a:xfrm>
-          <a:prstGeom prst="rect">
-            <a:avLst/>
-          </a:prstGeom>
-          <a:noFill/>
-        </p:spPr>
-        <p:txBody>
-          <a:bodyPr wrap="square" lIns="0" rIns="0" tIns="0" bIns="0">
-            <a:spAutoFit/>
-          </a:bodyPr>
-          <a:lstStyle/>
-          <a:p>
-            <a:pPr>
-              <a:lnSpc>
-                <a:spcPct val="115000"/>
-              </a:lnSpc>
-              <a:spcAft>
-                <a:spcPts val="792"/>
-              </a:spcAft>
-            </a:pPr>
-            <a:r>
-              <a:rPr sz="744">
-                <a:solidFill>
-                  <a:srgbClr val="B06A00"/>
-                </a:solidFill>
-              </a:rPr>
-              <a:t>■  </a:t>
-            </a:r>
-            <a:r>
-              <a:rPr sz="1200" b="0">
-                <a:solidFill>
-                  <a:srgbClr val="121826"/>
-                </a:solidFill>
-                <a:latin typeface="Calibri"/>
-              </a:rPr>
-              <a:t>Accumulate passages across retries — one field, and the change most likely to improve answers.</a:t>
-            </a:r>
-          </a:p>
-          <a:p>
-            <a:pPr>
-              <a:lnSpc>
-                <a:spcPct val="115000"/>
-              </a:lnSpc>
-              <a:spcAft>
-                <a:spcPts val="792"/>
-              </a:spcAft>
-            </a:pPr>
-            <a:r>
-              <a:rPr sz="744">
-                <a:solidFill>
-                  <a:srgbClr val="B06A00"/>
-                </a:solidFill>
-              </a:rPr>
-              <a:t>■  </a:t>
-            </a:r>
-            <a:r>
-              <a:rPr sz="1200" b="0">
-                <a:solidFill>
-                  <a:srgbClr val="121826"/>
-                </a:solidFill>
-                <a:latin typeface="Calibri"/>
-              </a:rPr>
-              <a:t>A recall eval, to close the one gap above I cannot currently answer.</a:t>
-            </a:r>
-          </a:p>
-          <a:p>
-            <a:pPr>
-              <a:lnSpc>
-                <a:spcPct val="115000"/>
-              </a:lnSpc>
-              <a:spcAft>
-                <a:spcPts val="792"/>
-              </a:spcAft>
-            </a:pPr>
-            <a:r>
-              <a:rPr sz="744">
-                <a:solidFill>
-                  <a:srgbClr val="B06A00"/>
-                </a:solidFill>
-              </a:rPr>
-              <a:t>■  </a:t>
-            </a:r>
-            <a:r>
-              <a:rPr sz="1200" b="0">
-                <a:solidFill>
-                  <a:srgbClr val="121826"/>
-                </a:solidFill>
-                <a:latin typeface="Calibri"/>
-              </a:rPr>
-              <a:t>Link citations to EDGAR — the source URL is already stored on every chunk.</a:t>
-            </a:r>
-          </a:p>
-        </p:txBody>
-      </p:sp>
-      <p:sp>
-        <p:nvSpPr>
-          <p:cNvPr id="12" name="Rectangle 11"/>
-          <p:cNvSpPr/>
-          <p:nvPr/>
-        </p:nvSpPr>
-        <p:spPr>
-          <a:xfrm>
-            <a:off x="685800" y="5687568"/>
-            <a:ext cx="10820095" cy="10972"/>
-          </a:xfrm>
-          <a:prstGeom prst="rect">
-            <a:avLst/>
-          </a:prstGeom>
-          <a:solidFill>
-            <a:srgbClr val="DBE2ED"/>
-          </a:solidFill>
-          <a:ln>
-            <a:noFill/>
-          </a:ln>
-          <a:effectLst/>
-        </p:spPr>
-        <p:style>
-          <a:lnRef idx="1">
-            <a:schemeClr val="accent1"/>
-          </a:lnRef>
-          <a:fillRef idx="3">
-            <a:schemeClr val="accent1"/>
-          </a:fillRef>
-          <a:effectRef idx="2">
-            <a:schemeClr val="accent1"/>
-          </a:effectRef>
-          <a:fontRef idx="minor">
-            <a:schemeClr val="lt1"/>
-          </a:fontRef>
-        </p:style>
-        <p:txBody>
-          <a:bodyPr rtlCol="0" anchor="ctr"/>
-          <a:lstStyle/>
-          <a:p>
-            <a:pPr algn="ctr"/>
-          </a:p>
-        </p:txBody>
-      </p:sp>
-      <p:sp>
-        <p:nvSpPr>
-          <p:cNvPr id="13" name="TextBox 12"/>
-          <p:cNvSpPr txBox="1"/>
-          <p:nvPr/>
-        </p:nvSpPr>
-        <p:spPr>
-          <a:xfrm>
-            <a:off x="685800" y="5815583"/>
+            <a:off x="685800" y="5333555"/>
             <a:ext cx="10820095" cy="822960"/>
           </a:xfrm>
           <a:prstGeom prst="rect">

</xml_diff>